<commit_message>
Shorten proposal notes and add five-minute slide schedule
</commit_message>
<xml_diff>
--- a/docs/presentation/IQL_RL_Proposal.pptx
+++ b/docs/presentation/IQL_RL_Proposal.pptx
@@ -449,7 +449,7 @@
           <a:lstStyle xmlns:a="http://schemas.openxmlformats.org/drawingml/2006/main"/>
           <a:p xmlns:a="http://schemas.openxmlformats.org/drawingml/2006/main">
             <a:r>
-              <a:t>20 seconds. Suggested speaker: Aleksandr Medvedev.</a:t>
+              <a:t>0:00-0:10</a:t>
             </a:r>
           </a:p>
           <a:p xmlns:a="http://schemas.openxmlformats.org/drawingml/2006/main">
@@ -459,7 +459,7 @@
           </a:p>
           <a:p xmlns:a="http://schemas.openxmlformats.org/drawingml/2006/main">
             <a:r>
-              <a:t>Our project uses Implicit Q-Learning, or IQL, to learn continuous locomotion from recorded data. We will explain how the algorithm works, what HalfCheetah requires, and why this combination is suitable. The final slide shows measured feasibility evidence from our existing project.</a:t>
+              <a:t>Our project uses Implicit Q-Learning to teach HalfCheetah efficient locomotion from recorded data.</a:t>
             </a:r>
           </a:p>
           <a:p xmlns:a="http://schemas.openxmlformats.org/drawingml/2006/main">
@@ -469,27 +469,7 @@
           </a:p>
           <a:p xmlns:a="http://schemas.openxmlformats.org/drawingml/2006/main">
             <a:r>
-              <a:t>Show: Introduce the title and team. Point to the actual HalfCheetah rollout image; hold briefly before advancing.</a:t>
-            </a:r>
-          </a:p>
-          <a:p xmlns:a="http://schemas.openxmlformats.org/drawingml/2006/main">
-            <a:r>
-              <a:t/>
-            </a:r>
-          </a:p>
-          <a:p xmlns:a="http://schemas.openxmlformats.org/drawingml/2006/main">
-            <a:r>
-              <a:t>Sources:</a:t>
-            </a:r>
-          </a:p>
-          <a:p xmlns:a="http://schemas.openxmlformats.org/drawingml/2006/main">
-            <a:r>
-              <a:t>https://github.com/MedvAx-AI/iql-halfcheetah</a:t>
-            </a:r>
-          </a:p>
-          <a:p xmlns:a="http://schemas.openxmlformats.org/drawingml/2006/main">
-            <a:r>
-              <a:t>Image: actual project rollout, seed 1 at 500k, evaluation seed 10000, frame at 20 seconds. https://github.com/MedvAx-AI/iql-halfcheetah/releases/tag/policy-continuation-experiment</a:t>
+              <a:t>Sources: [1], [4]. Full references: SLIDE_SOURCES.md.</a:t>
             </a:r>
           </a:p>
         </p:txBody>
@@ -559,7 +539,7 @@
           <a:lstStyle xmlns:a="http://schemas.openxmlformats.org/drawingml/2006/main"/>
           <a:p xmlns:a="http://schemas.openxmlformats.org/drawingml/2006/main">
             <a:r>
-              <a:t>50 seconds. Suggested speaker: Leo Vesin.</a:t>
+              <a:t>0:10-0:45</a:t>
             </a:r>
           </a:p>
           <a:p xmlns:a="http://schemas.openxmlformats.org/drawingml/2006/main">
@@ -569,7 +549,7 @@
           </a:p>
           <a:p xmlns:a="http://schemas.openxmlformats.org/drawingml/2006/main">
             <a:r>
-              <a:t>IQL is offline, model-free actor-critic reinforcement learning. Training starts with a fixed dataset of observations, actions, rewards and next observations. The diagram separates learning from evaluation. IQL estimates values using recorded actions, then trains the actor to imitate stronger actions more heavily. It avoids explicitly maximizing the value backup over unseen actions. The simulator is used to evaluate the policy after training, rather than collect new training data. The policy produces six bounded torque controls at each step.</a:t>
+              <a:t>IQL is offline, model-free actor-critic learning. It trains on fixed transitions, then gives better recorded actions more weight when fitting the policy. The actor outputs six continuous torques. Simulator rollouts evaluate the learned policy, without collecting new training data.</a:t>
             </a:r>
           </a:p>
           <a:p xmlns:a="http://schemas.openxmlformats.org/drawingml/2006/main">
@@ -579,27 +559,7 @@
           </a:p>
           <a:p xmlns:a="http://schemas.openxmlformats.org/drawingml/2006/main">
             <a:r>
-              <a:t>Show: Follow the upper diagram from recorded transitions to learner to policy. Point to the separate simulator evaluation path. Pause so the audience can follow the distinction.</a:t>
-            </a:r>
-          </a:p>
-          <a:p xmlns:a="http://schemas.openxmlformats.org/drawingml/2006/main">
-            <a:r>
-              <a:t/>
-            </a:r>
-          </a:p>
-          <a:p xmlns:a="http://schemas.openxmlformats.org/drawingml/2006/main">
-            <a:r>
-              <a:t>Sources:</a:t>
-            </a:r>
-          </a:p>
-          <a:p xmlns:a="http://schemas.openxmlformats.org/drawingml/2006/main">
-            <a:r>
-              <a:t>https://arxiv.org/abs/2110.06169</a:t>
-            </a:r>
-          </a:p>
-          <a:p xmlns:a="http://schemas.openxmlformats.org/drawingml/2006/main">
-            <a:r>
-              <a:t>https://github.com/ikostrikov/implicit_q_learning</a:t>
+              <a:t>Sources: [1]. Full references: SLIDE_SOURCES.md.</a:t>
             </a:r>
           </a:p>
         </p:txBody>
@@ -669,7 +629,7 @@
           <a:lstStyle xmlns:a="http://schemas.openxmlformats.org/drawingml/2006/main"/>
           <a:p xmlns:a="http://schemas.openxmlformats.org/drawingml/2006/main">
             <a:r>
-              <a:t>50 seconds. Suggested speaker: Leo Vesin.</a:t>
+              <a:t>0:45-1:30</a:t>
             </a:r>
           </a:p>
           <a:p xmlns:a="http://schemas.openxmlformats.org/drawingml/2006/main">
@@ -679,7 +639,7 @@
           </a:p>
           <a:p xmlns:a="http://schemas.openxmlformats.org/drawingml/2006/main">
             <a:r>
-              <a:t>The learner has three updates. First, the state-value network uses an upper expectile of zero point seven, emphasizing higher-valued recorded actions. Second, the twin Q networks fit reward plus discounted next-state value, with discount zero point nine nine. Third, the actor fits recorded actions using advantage weights: the exponential of three times advantage, capped at one hundred. Advantage is the minimum target-critic estimate minus the state value. Three is inverse temperature. A tanh-squashed Gaussian keeps the actor's outputs within the action bounds. The repeated updates improve the policy without changing the fixed dataset.</a:t>
+              <a:t>IQL updates three components. The value network uses expectile 0.7 to favor stronger recorded actions. Twin critics fit reward plus discounted next-state value, with discount 0.99. The actor imitates actions using advantage weights, capped at 100. Advantage is minimum target Q minus V. The weight uses inverse temperature 3. A tanh-squashed Gaussian keeps actions bounded.</a:t>
             </a:r>
           </a:p>
           <a:p xmlns:a="http://schemas.openxmlformats.org/drawingml/2006/main">
@@ -689,32 +649,7 @@
           </a:p>
           <a:p xmlns:a="http://schemas.openxmlformats.org/drawingml/2006/main">
             <a:r>
-              <a:t>Show: Explain each update in order. Point to 0.7, 0.99 and the weight cap of 100. Read the equations in words and allow brief pauses.</a:t>
-            </a:r>
-          </a:p>
-          <a:p xmlns:a="http://schemas.openxmlformats.org/drawingml/2006/main">
-            <a:r>
-              <a:t/>
-            </a:r>
-          </a:p>
-          <a:p xmlns:a="http://schemas.openxmlformats.org/drawingml/2006/main">
-            <a:r>
-              <a:t>Sources:</a:t>
-            </a:r>
-          </a:p>
-          <a:p xmlns:a="http://schemas.openxmlformats.org/drawingml/2006/main">
-            <a:r>
-              <a:t>https://arxiv.org/abs/2110.06169</a:t>
-            </a:r>
-          </a:p>
-          <a:p xmlns:a="http://schemas.openxmlformats.org/drawingml/2006/main">
-            <a:r>
-              <a:t>https://github.com/MedvAx-AI/iql-halfcheetah/blob/c372ec0423b81839956ec00dd7338700db8d3737/src/iql_project/iql.py</a:t>
-            </a:r>
-          </a:p>
-          <a:p xmlns:a="http://schemas.openxmlformats.org/drawingml/2006/main">
-            <a:r>
-              <a:t>https://github.com/MedvAx-AI/iql-halfcheetah/blob/c372ec0423b81839956ec00dd7338700db8d3737/configs/halfcheetah.toml</a:t>
+              <a:t>Sources: [1], [3]. Full references: SLIDE_SOURCES.md.</a:t>
             </a:r>
           </a:p>
         </p:txBody>
@@ -784,7 +719,7 @@
           <a:lstStyle xmlns:a="http://schemas.openxmlformats.org/drawingml/2006/main"/>
           <a:p xmlns:a="http://schemas.openxmlformats.org/drawingml/2006/main">
             <a:r>
-              <a:t>65 seconds. Suggested speaker: Nikita Shankin.</a:t>
+              <a:t>1:30-2:30</a:t>
             </a:r>
           </a:p>
           <a:p xmlns:a="http://schemas.openxmlformats.org/drawingml/2006/main">
@@ -794,7 +729,7 @@
           </a:p>
           <a:p xmlns:a="http://schemas.openxmlformats.org/drawingml/2006/main">
             <a:r>
-              <a:t>HalfCheetah version five is a two-dimensional locomotion task in Gymnasium and MuJoCo. The robot has front and back legs. Its seventeen-value observation combines eight position or angle values with nine velocities. These describe the robot's pose and motion. Absolute horizontal position is excluded from the default observation. The action has six continuous torque components: thigh, shin and foot on each leg. Every component lies between minus one and one. The policy must use the current observation to coordinate these joints into a useful gait. The image comes from a real project rollout, while the color split shows the observation structure.</a:t>
+              <a:t>HalfCheetah-v5 is a two-dimensional locomotion task in Gymnasium and MuJoCo. Its 17 observations contain eight pose values and nine velocities. Absolute horizontal position is excluded. Six actions control the thigh, shin and foot on both legs. Each torque lies between minus one and one. The agent must coordinate these joints into a sustained forward gait.</a:t>
             </a:r>
           </a:p>
           <a:p xmlns:a="http://schemas.openxmlformats.org/drawingml/2006/main">
@@ -804,27 +739,7 @@
           </a:p>
           <a:p xmlns:a="http://schemas.openxmlformats.org/drawingml/2006/main">
             <a:r>
-              <a:t>Show: Point to the actual robot, then trace the 8 plus 9 observation split. Explain the three joints on each of two legs and the action bound. Leave time for the audience to inspect the image.</a:t>
-            </a:r>
-          </a:p>
-          <a:p xmlns:a="http://schemas.openxmlformats.org/drawingml/2006/main">
-            <a:r>
-              <a:t/>
-            </a:r>
-          </a:p>
-          <a:p xmlns:a="http://schemas.openxmlformats.org/drawingml/2006/main">
-            <a:r>
-              <a:t>Sources:</a:t>
-            </a:r>
-          </a:p>
-          <a:p xmlns:a="http://schemas.openxmlformats.org/drawingml/2006/main">
-            <a:r>
-              <a:t>https://gymnasium.farama.org/environments/mujoco/half_cheetah/</a:t>
-            </a:r>
-          </a:p>
-          <a:p xmlns:a="http://schemas.openxmlformats.org/drawingml/2006/main">
-            <a:r>
-              <a:t>Image: actual project rollout, seed 1 at 500k, evaluation seed 10000, frame at 0 seconds. https://github.com/MedvAx-AI/iql-halfcheetah/releases/tag/policy-continuation-experiment</a:t>
+              <a:t>Sources: [2], [4]. Full references: SLIDE_SOURCES.md.</a:t>
             </a:r>
           </a:p>
         </p:txBody>
@@ -894,7 +809,7 @@
           <a:lstStyle xmlns:a="http://schemas.openxmlformats.org/drawingml/2006/main"/>
           <a:p xmlns:a="http://schemas.openxmlformats.org/drawingml/2006/main">
             <a:r>
-              <a:t>55 seconds. Suggested speaker: Nikita Shankin.</a:t>
+              <a:t>2:30-3:30</a:t>
             </a:r>
           </a:p>
           <a:p xmlns:a="http://schemas.openxmlformats.org/drawingml/2006/main">
@@ -904,7 +819,7 @@
           </a:p>
           <a:p xmlns:a="http://schemas.openxmlformats.org/drawingml/2006/main">
             <a:r>
-              <a:t>The default reward is forward velocity minus zero point one times squared control effort. The numerical example is illustrative: at five meters per second, six action components of zero point five produce a cost of zero point fifteen, so the reward is four point eight five. This encourages efficient forward motion. The agent should learn a gait that maintains speed throughout the episode. A fall does not terminate HalfCheetah. The time limit is one thousand steps, about fifty simulated seconds. A failed policy can remain on the ground until that limit. Time-limit truncation still preserves next-state value bootstrapping in our learning targets.</a:t>
+              <a:t>Reward is forward velocity minus 0.1 times squared action effort. In this example, speed contributes 5 and control costs 0.15, giving 4.85 reward. The goal is efficient, sustained forward motion. A fall does not end HalfCheetah: the episode lasts 1,000 steps, about 50 simulated seconds. Time-limit truncation preserves next-state value bootstrapping. We inspect complete episodes to detect falls and stalls.</a:t>
             </a:r>
           </a:p>
           <a:p xmlns:a="http://schemas.openxmlformats.org/drawingml/2006/main">
@@ -914,27 +829,7 @@
           </a:p>
           <a:p xmlns:a="http://schemas.openxmlformats.org/drawingml/2006/main">
             <a:r>
-              <a:t>Show: Follow the numerical reward example from speed through effort cost to net reward. Trace the 0-to-50-second episode line. Emphasize that a fall does not end the episode.</a:t>
-            </a:r>
-          </a:p>
-          <a:p xmlns:a="http://schemas.openxmlformats.org/drawingml/2006/main">
-            <a:r>
-              <a:t/>
-            </a:r>
-          </a:p>
-          <a:p xmlns:a="http://schemas.openxmlformats.org/drawingml/2006/main">
-            <a:r>
-              <a:t>Sources:</a:t>
-            </a:r>
-          </a:p>
-          <a:p xmlns:a="http://schemas.openxmlformats.org/drawingml/2006/main">
-            <a:r>
-              <a:t>https://gymnasium.farama.org/environments/mujoco/half_cheetah/</a:t>
-            </a:r>
-          </a:p>
-          <a:p xmlns:a="http://schemas.openxmlformats.org/drawingml/2006/main">
-            <a:r>
-              <a:t>https://github.com/MedvAx-AI/iql-halfcheetah/blob/c372ec0423b81839956ec00dd7338700db8d3737/src/iql_project/iql.py</a:t>
+              <a:t>Sources: [2], [3]. Full references: SLIDE_SOURCES.md.</a:t>
             </a:r>
           </a:p>
         </p:txBody>
@@ -1004,7 +899,7 @@
           <a:lstStyle xmlns:a="http://schemas.openxmlformats.org/drawingml/2006/main"/>
           <a:p xmlns:a="http://schemas.openxmlformats.org/drawingml/2006/main">
             <a:r>
-              <a:t>40 seconds. Suggested speaker: Ruslan Nasibullin.</a:t>
+              <a:t>3:30-3:50</a:t>
             </a:r>
           </a:p>
           <a:p xmlns:a="http://schemas.openxmlformats.org/drawingml/2006/main">
@@ -1014,7 +909,7 @@
           </a:p>
           <a:p xmlns:a="http://schemas.openxmlformats.org/drawingml/2006/main">
             <a:r>
-              <a:t>We use Minari's HalfCheetah medium dataset: one million transitions from one thousand episodes. Our protocol trains three seeds for five hundred thousand offline updates each, with batches of two hundred fifty-six. We evaluate checkpoints over ten episodes, compare raw return with a random baseline, then test the selected checkpoint on separate final episode seeds. We retain full videos and separate episode variation from training-seed variation. MuJoCo three point two point three matches the recorded dataset runtime.</a:t>
+              <a:t>We use one million Minari transitions. Three training seeds receive 500k updates each. Checkpoints use ten evaluation episodes and a random baseline. The selected policy then uses separate final-test seeds. We retain full videos and pin MuJoCo 3.2.3 for reproducibility.</a:t>
             </a:r>
           </a:p>
           <a:p xmlns:a="http://schemas.openxmlformats.org/drawingml/2006/main">
@@ -1024,27 +919,7 @@
           </a:p>
           <a:p xmlns:a="http://schemas.openxmlformats.org/drawingml/2006/main">
             <a:r>
-              <a:t>Show: Point to the large dataset and budget numbers, then follow the training-to-selection-to-final-test timeline. Distinguish training seeds from evaluation episode seeds.</a:t>
-            </a:r>
-          </a:p>
-          <a:p xmlns:a="http://schemas.openxmlformats.org/drawingml/2006/main">
-            <a:r>
-              <a:t/>
-            </a:r>
-          </a:p>
-          <a:p xmlns:a="http://schemas.openxmlformats.org/drawingml/2006/main">
-            <a:r>
-              <a:t>Sources:</a:t>
-            </a:r>
-          </a:p>
-          <a:p xmlns:a="http://schemas.openxmlformats.org/drawingml/2006/main">
-            <a:r>
-              <a:t>https://minari.farama.org/datasets/mujoco/halfcheetah/medium-v0/</a:t>
-            </a:r>
-          </a:p>
-          <a:p xmlns:a="http://schemas.openxmlformats.org/drawingml/2006/main">
-            <a:r>
-              <a:t>https://github.com/MedvAx-AI/iql-halfcheetah/blob/c372ec0423b81839956ec00dd7338700db8d3737/docs/POLICY_CONTINUATION.md</a:t>
+              <a:t>Sources: [3], [5]. Full references: SLIDE_SOURCES.md.</a:t>
             </a:r>
           </a:p>
         </p:txBody>
@@ -1114,7 +989,7 @@
           <a:lstStyle xmlns:a="http://schemas.openxmlformats.org/drawingml/2006/main"/>
           <a:p xmlns:a="http://schemas.openxmlformats.org/drawingml/2006/main">
             <a:r>
-              <a:t>60 seconds. Suggested speaker: Telman Nuruzov.</a:t>
+              <a:t>3:50-4:30</a:t>
             </a:r>
           </a:p>
           <a:p xmlns:a="http://schemas.openxmlformats.org/drawingml/2006/main">
@@ -1124,7 +999,7 @@
           </a:p>
           <a:p xmlns:a="http://schemas.openxmlformats.org/drawingml/2006/main">
             <a:r>
-              <a:t>The match has three practical reasons. Continuous joint torques fit a continuous actor directly. Available offline locomotion data makes training feasible without a new data-collection stage. Finally, numerical returns and visible movement make evaluation understandable. IQL's advantage weighting can favor better recorded actions, but improvement is something to test, not assume. The main challenges are limited coverage, policy variation and simulator differences. We address them with multiple training seeds, pinned dependencies and full-episode evaluation. Aleksandr owns integration, Nikita the environment and data, Leo IQL, Ruslan evaluation, and Telman the notebook and presentation. Our shared outputs are a reproducible Colab, checkpoints, plots and complete rollouts.</a:t>
+              <a:t>HalfCheetah fits IQL because it has continuous controls, available offline data, and measurable locomotion. Advantage weighting can favor better actions, but improvement must be tested. Main challenges are data coverage, seed failures and physics differences. We address them with multiple seeds, pinned dependencies and full-episode evaluation. Team responsibilities and deliverables appear here.</a:t>
             </a:r>
           </a:p>
           <a:p xmlns:a="http://schemas.openxmlformats.org/drawingml/2006/main">
@@ -1134,32 +1009,7 @@
           </a:p>
           <a:p xmlns:a="http://schemas.openxmlformats.org/drawingml/2006/main">
             <a:r>
-              <a:t>Show: Follow the three algorithm-to-task matches. Explain the challenges along the bottom. Point to the team ownership line and name each personâ€™s contribution without reading all slide labels aloud.</a:t>
-            </a:r>
-          </a:p>
-          <a:p xmlns:a="http://schemas.openxmlformats.org/drawingml/2006/main">
-            <a:r>
-              <a:t/>
-            </a:r>
-          </a:p>
-          <a:p xmlns:a="http://schemas.openxmlformats.org/drawingml/2006/main">
-            <a:r>
-              <a:t>Sources:</a:t>
-            </a:r>
-          </a:p>
-          <a:p xmlns:a="http://schemas.openxmlformats.org/drawingml/2006/main">
-            <a:r>
-              <a:t>https://arxiv.org/abs/2110.06169</a:t>
-            </a:r>
-          </a:p>
-          <a:p xmlns:a="http://schemas.openxmlformats.org/drawingml/2006/main">
-            <a:r>
-              <a:t>https://minari.farama.org/datasets/mujoco/halfcheetah/medium-v0/</a:t>
-            </a:r>
-          </a:p>
-          <a:p xmlns:a="http://schemas.openxmlformats.org/drawingml/2006/main">
-            <a:r>
-              <a:t>https://gymnasium.farama.org/environments/mujoco/half_cheetah/</a:t>
+              <a:t>Sources: [1], [2], [3]. Full references: SLIDE_SOURCES.md.</a:t>
             </a:r>
           </a:p>
         </p:txBody>
@@ -1229,7 +1079,7 @@
           <a:lstStyle xmlns:a="http://schemas.openxmlformats.org/drawingml/2006/main"/>
           <a:p xmlns:a="http://schemas.openxmlformats.org/drawingml/2006/main">
             <a:r>
-              <a:t>50 seconds. Suggested speaker: Aleksandr Medvedev.</a:t>
+              <a:t>4:30-5:00</a:t>
             </a:r>
           </a:p>
           <a:p xmlns:a="http://schemas.openxmlformats.org/drawingml/2006/main">
@@ -1239,7 +1089,7 @@
           </a:p>
           <a:p xmlns:a="http://schemas.openxmlformats.org/drawingml/2006/main">
             <a:r>
-              <a:t>This chart shows recorded Colab validation means for all three training seeds at five measured checkpoints. Each point averages ten episodes. Performance varies across seeds, and the lines do not claim values between measurements. The selected seed-one policy reached a raw return of about fifteen thousand two hundred sixty on ten separate final-test episodes, compared with about two thousand twenty-six at one hundred thousand updates. Long stationary tails decreased from ten out of ten episodes to zero out of ten. Those tails mean at least five seconds of very slow movement at the end. Other training seeds still fail, and these samples do not guarantee success everywhere. The evidence supports feasibility while preserving the limits. Thank you.</a:t>
+              <a:t>The curves show measured means for all three training seeds, with ten episodes per point. On ten separate final-test episodes, selected seed 1 achieved about 15,260 return versus 2,026 at 100k. Long stationary tails decreased from ten episodes to zero. Other training seeds still fail, so these results demonstrate feasibility rather than guaranteed success. Thank you.</a:t>
             </a:r>
           </a:p>
           <a:p xmlns:a="http://schemas.openxmlformats.org/drawingml/2006/main">
@@ -1249,42 +1099,7 @@
           </a:p>
           <a:p xmlns:a="http://schemas.openxmlformats.org/drawingml/2006/main">
             <a:r>
-              <a:t>Show: Trace all three measured curves. Point to the separate final-test return and stationary-tail counts. Say the other-seed limitation clearly, then pause on the closing slide.</a:t>
-            </a:r>
-          </a:p>
-          <a:p xmlns:a="http://schemas.openxmlformats.org/drawingml/2006/main">
-            <a:r>
-              <a:t/>
-            </a:r>
-          </a:p>
-          <a:p xmlns:a="http://schemas.openxmlformats.org/drawingml/2006/main">
-            <a:r>
-              <a:t>Sources:</a:t>
-            </a:r>
-          </a:p>
-          <a:p xmlns:a="http://schemas.openxmlformats.org/drawingml/2006/main">
-            <a:r>
-              <a:t>https://github.com/MedvAx-AI/iql-halfcheetah</a:t>
-            </a:r>
-          </a:p>
-          <a:p xmlns:a="http://schemas.openxmlformats.org/drawingml/2006/main">
-            <a:r>
-              <a:t>https://github.com/MedvAx-AI/iql-halfcheetah/blob/c372ec0423b81839956ec00dd7338700db8d3737/docs/POLICY_CONTINUATION.md</a:t>
-            </a:r>
-          </a:p>
-          <a:p xmlns:a="http://schemas.openxmlformats.org/drawingml/2006/main">
-            <a:r>
-              <a:t>https://github.com/MedvAx-AI/iql-halfcheetah/blob/aa9ad5baec910730502e1f24459325b5f273b952/docs/evidence/continuation/validation/summary.json</a:t>
-            </a:r>
-          </a:p>
-          <a:p xmlns:a="http://schemas.openxmlformats.org/drawingml/2006/main">
-            <a:r>
-              <a:t>https://github.com/MedvAx-AI/iql-halfcheetah/blob/aa9ad5baec910730502e1f24459325b5f273b952/docs/evidence/continuation/independent-final-test.json</a:t>
-            </a:r>
-          </a:p>
-          <a:p xmlns:a="http://schemas.openxmlformats.org/drawingml/2006/main">
-            <a:r>
-              <a:t>Long stationary tail: at least 5 seconds at the end with absolute forward velocity &lt;= 0.1 m/s. Descriptive diagnostic, not a standard benchmark success score.</a:t>
+              <a:t>Sources: [6]. Full references: SLIDE_SOURCES.md.</a:t>
             </a:r>
           </a:p>
         </p:txBody>

</xml_diff>

<commit_message>
Shorten speaker notes for a five-minute proposal (#20)
* Shorten proposal notes and add five-minute slide schedule

* Link full slide references from presentation index

---------

Co-authored-by: MedvAx-AI <188178945+MedvAx-AI@users.noreply.github.com>
</commit_message>
<xml_diff>
--- a/docs/presentation/IQL_RL_Proposal.pptx
+++ b/docs/presentation/IQL_RL_Proposal.pptx
@@ -449,7 +449,7 @@
           <a:lstStyle xmlns:a="http://schemas.openxmlformats.org/drawingml/2006/main"/>
           <a:p xmlns:a="http://schemas.openxmlformats.org/drawingml/2006/main">
             <a:r>
-              <a:t>20 seconds. Suggested speaker: Aleksandr Medvedev.</a:t>
+              <a:t>0:00-0:10</a:t>
             </a:r>
           </a:p>
           <a:p xmlns:a="http://schemas.openxmlformats.org/drawingml/2006/main">
@@ -459,7 +459,7 @@
           </a:p>
           <a:p xmlns:a="http://schemas.openxmlformats.org/drawingml/2006/main">
             <a:r>
-              <a:t>Our project uses Implicit Q-Learning, or IQL, to learn continuous locomotion from recorded data. We will explain how the algorithm works, what HalfCheetah requires, and why this combination is suitable. The final slide shows measured feasibility evidence from our existing project.</a:t>
+              <a:t>Our project uses Implicit Q-Learning to teach HalfCheetah efficient locomotion from recorded data.</a:t>
             </a:r>
           </a:p>
           <a:p xmlns:a="http://schemas.openxmlformats.org/drawingml/2006/main">
@@ -469,27 +469,7 @@
           </a:p>
           <a:p xmlns:a="http://schemas.openxmlformats.org/drawingml/2006/main">
             <a:r>
-              <a:t>Show: Introduce the title and team. Point to the actual HalfCheetah rollout image; hold briefly before advancing.</a:t>
-            </a:r>
-          </a:p>
-          <a:p xmlns:a="http://schemas.openxmlformats.org/drawingml/2006/main">
-            <a:r>
-              <a:t/>
-            </a:r>
-          </a:p>
-          <a:p xmlns:a="http://schemas.openxmlformats.org/drawingml/2006/main">
-            <a:r>
-              <a:t>Sources:</a:t>
-            </a:r>
-          </a:p>
-          <a:p xmlns:a="http://schemas.openxmlformats.org/drawingml/2006/main">
-            <a:r>
-              <a:t>https://github.com/MedvAx-AI/iql-halfcheetah</a:t>
-            </a:r>
-          </a:p>
-          <a:p xmlns:a="http://schemas.openxmlformats.org/drawingml/2006/main">
-            <a:r>
-              <a:t>Image: actual project rollout, seed 1 at 500k, evaluation seed 10000, frame at 20 seconds. https://github.com/MedvAx-AI/iql-halfcheetah/releases/tag/policy-continuation-experiment</a:t>
+              <a:t>Sources: [1], [4]. Full references: SLIDE_SOURCES.md.</a:t>
             </a:r>
           </a:p>
         </p:txBody>
@@ -559,7 +539,7 @@
           <a:lstStyle xmlns:a="http://schemas.openxmlformats.org/drawingml/2006/main"/>
           <a:p xmlns:a="http://schemas.openxmlformats.org/drawingml/2006/main">
             <a:r>
-              <a:t>50 seconds. Suggested speaker: Leo Vesin.</a:t>
+              <a:t>0:10-0:45</a:t>
             </a:r>
           </a:p>
           <a:p xmlns:a="http://schemas.openxmlformats.org/drawingml/2006/main">
@@ -569,7 +549,7 @@
           </a:p>
           <a:p xmlns:a="http://schemas.openxmlformats.org/drawingml/2006/main">
             <a:r>
-              <a:t>IQL is offline, model-free actor-critic reinforcement learning. Training starts with a fixed dataset of observations, actions, rewards and next observations. The diagram separates learning from evaluation. IQL estimates values using recorded actions, then trains the actor to imitate stronger actions more heavily. It avoids explicitly maximizing the value backup over unseen actions. The simulator is used to evaluate the policy after training, rather than collect new training data. The policy produces six bounded torque controls at each step.</a:t>
+              <a:t>IQL is offline, model-free actor-critic learning. It trains on fixed transitions, then gives better recorded actions more weight when fitting the policy. The actor outputs six continuous torques. Simulator rollouts evaluate the learned policy, without collecting new training data.</a:t>
             </a:r>
           </a:p>
           <a:p xmlns:a="http://schemas.openxmlformats.org/drawingml/2006/main">
@@ -579,27 +559,7 @@
           </a:p>
           <a:p xmlns:a="http://schemas.openxmlformats.org/drawingml/2006/main">
             <a:r>
-              <a:t>Show: Follow the upper diagram from recorded transitions to learner to policy. Point to the separate simulator evaluation path. Pause so the audience can follow the distinction.</a:t>
-            </a:r>
-          </a:p>
-          <a:p xmlns:a="http://schemas.openxmlformats.org/drawingml/2006/main">
-            <a:r>
-              <a:t/>
-            </a:r>
-          </a:p>
-          <a:p xmlns:a="http://schemas.openxmlformats.org/drawingml/2006/main">
-            <a:r>
-              <a:t>Sources:</a:t>
-            </a:r>
-          </a:p>
-          <a:p xmlns:a="http://schemas.openxmlformats.org/drawingml/2006/main">
-            <a:r>
-              <a:t>https://arxiv.org/abs/2110.06169</a:t>
-            </a:r>
-          </a:p>
-          <a:p xmlns:a="http://schemas.openxmlformats.org/drawingml/2006/main">
-            <a:r>
-              <a:t>https://github.com/ikostrikov/implicit_q_learning</a:t>
+              <a:t>Sources: [1]. Full references: SLIDE_SOURCES.md.</a:t>
             </a:r>
           </a:p>
         </p:txBody>
@@ -669,7 +629,7 @@
           <a:lstStyle xmlns:a="http://schemas.openxmlformats.org/drawingml/2006/main"/>
           <a:p xmlns:a="http://schemas.openxmlformats.org/drawingml/2006/main">
             <a:r>
-              <a:t>50 seconds. Suggested speaker: Leo Vesin.</a:t>
+              <a:t>0:45-1:30</a:t>
             </a:r>
           </a:p>
           <a:p xmlns:a="http://schemas.openxmlformats.org/drawingml/2006/main">
@@ -679,7 +639,7 @@
           </a:p>
           <a:p xmlns:a="http://schemas.openxmlformats.org/drawingml/2006/main">
             <a:r>
-              <a:t>The learner has three updates. First, the state-value network uses an upper expectile of zero point seven, emphasizing higher-valued recorded actions. Second, the twin Q networks fit reward plus discounted next-state value, with discount zero point nine nine. Third, the actor fits recorded actions using advantage weights: the exponential of three times advantage, capped at one hundred. Advantage is the minimum target-critic estimate minus the state value. Three is inverse temperature. A tanh-squashed Gaussian keeps the actor's outputs within the action bounds. The repeated updates improve the policy without changing the fixed dataset.</a:t>
+              <a:t>IQL updates three components. The value network uses expectile 0.7 to favor stronger recorded actions. Twin critics fit reward plus discounted next-state value, with discount 0.99. The actor imitates actions using advantage weights, capped at 100. Advantage is minimum target Q minus V. The weight uses inverse temperature 3. A tanh-squashed Gaussian keeps actions bounded.</a:t>
             </a:r>
           </a:p>
           <a:p xmlns:a="http://schemas.openxmlformats.org/drawingml/2006/main">
@@ -689,32 +649,7 @@
           </a:p>
           <a:p xmlns:a="http://schemas.openxmlformats.org/drawingml/2006/main">
             <a:r>
-              <a:t>Show: Explain each update in order. Point to 0.7, 0.99 and the weight cap of 100. Read the equations in words and allow brief pauses.</a:t>
-            </a:r>
-          </a:p>
-          <a:p xmlns:a="http://schemas.openxmlformats.org/drawingml/2006/main">
-            <a:r>
-              <a:t/>
-            </a:r>
-          </a:p>
-          <a:p xmlns:a="http://schemas.openxmlformats.org/drawingml/2006/main">
-            <a:r>
-              <a:t>Sources:</a:t>
-            </a:r>
-          </a:p>
-          <a:p xmlns:a="http://schemas.openxmlformats.org/drawingml/2006/main">
-            <a:r>
-              <a:t>https://arxiv.org/abs/2110.06169</a:t>
-            </a:r>
-          </a:p>
-          <a:p xmlns:a="http://schemas.openxmlformats.org/drawingml/2006/main">
-            <a:r>
-              <a:t>https://github.com/MedvAx-AI/iql-halfcheetah/blob/c372ec0423b81839956ec00dd7338700db8d3737/src/iql_project/iql.py</a:t>
-            </a:r>
-          </a:p>
-          <a:p xmlns:a="http://schemas.openxmlformats.org/drawingml/2006/main">
-            <a:r>
-              <a:t>https://github.com/MedvAx-AI/iql-halfcheetah/blob/c372ec0423b81839956ec00dd7338700db8d3737/configs/halfcheetah.toml</a:t>
+              <a:t>Sources: [1], [3]. Full references: SLIDE_SOURCES.md.</a:t>
             </a:r>
           </a:p>
         </p:txBody>
@@ -784,7 +719,7 @@
           <a:lstStyle xmlns:a="http://schemas.openxmlformats.org/drawingml/2006/main"/>
           <a:p xmlns:a="http://schemas.openxmlformats.org/drawingml/2006/main">
             <a:r>
-              <a:t>65 seconds. Suggested speaker: Nikita Shankin.</a:t>
+              <a:t>1:30-2:30</a:t>
             </a:r>
           </a:p>
           <a:p xmlns:a="http://schemas.openxmlformats.org/drawingml/2006/main">
@@ -794,7 +729,7 @@
           </a:p>
           <a:p xmlns:a="http://schemas.openxmlformats.org/drawingml/2006/main">
             <a:r>
-              <a:t>HalfCheetah version five is a two-dimensional locomotion task in Gymnasium and MuJoCo. The robot has front and back legs. Its seventeen-value observation combines eight position or angle values with nine velocities. These describe the robot's pose and motion. Absolute horizontal position is excluded from the default observation. The action has six continuous torque components: thigh, shin and foot on each leg. Every component lies between minus one and one. The policy must use the current observation to coordinate these joints into a useful gait. The image comes from a real project rollout, while the color split shows the observation structure.</a:t>
+              <a:t>HalfCheetah-v5 is a two-dimensional locomotion task in Gymnasium and MuJoCo. Its 17 observations contain eight pose values and nine velocities. Absolute horizontal position is excluded. Six actions control the thigh, shin and foot on both legs. Each torque lies between minus one and one. The agent must coordinate these joints into a sustained forward gait.</a:t>
             </a:r>
           </a:p>
           <a:p xmlns:a="http://schemas.openxmlformats.org/drawingml/2006/main">
@@ -804,27 +739,7 @@
           </a:p>
           <a:p xmlns:a="http://schemas.openxmlformats.org/drawingml/2006/main">
             <a:r>
-              <a:t>Show: Point to the actual robot, then trace the 8 plus 9 observation split. Explain the three joints on each of two legs and the action bound. Leave time for the audience to inspect the image.</a:t>
-            </a:r>
-          </a:p>
-          <a:p xmlns:a="http://schemas.openxmlformats.org/drawingml/2006/main">
-            <a:r>
-              <a:t/>
-            </a:r>
-          </a:p>
-          <a:p xmlns:a="http://schemas.openxmlformats.org/drawingml/2006/main">
-            <a:r>
-              <a:t>Sources:</a:t>
-            </a:r>
-          </a:p>
-          <a:p xmlns:a="http://schemas.openxmlformats.org/drawingml/2006/main">
-            <a:r>
-              <a:t>https://gymnasium.farama.org/environments/mujoco/half_cheetah/</a:t>
-            </a:r>
-          </a:p>
-          <a:p xmlns:a="http://schemas.openxmlformats.org/drawingml/2006/main">
-            <a:r>
-              <a:t>Image: actual project rollout, seed 1 at 500k, evaluation seed 10000, frame at 0 seconds. https://github.com/MedvAx-AI/iql-halfcheetah/releases/tag/policy-continuation-experiment</a:t>
+              <a:t>Sources: [2], [4]. Full references: SLIDE_SOURCES.md.</a:t>
             </a:r>
           </a:p>
         </p:txBody>
@@ -894,7 +809,7 @@
           <a:lstStyle xmlns:a="http://schemas.openxmlformats.org/drawingml/2006/main"/>
           <a:p xmlns:a="http://schemas.openxmlformats.org/drawingml/2006/main">
             <a:r>
-              <a:t>55 seconds. Suggested speaker: Nikita Shankin.</a:t>
+              <a:t>2:30-3:30</a:t>
             </a:r>
           </a:p>
           <a:p xmlns:a="http://schemas.openxmlformats.org/drawingml/2006/main">
@@ -904,7 +819,7 @@
           </a:p>
           <a:p xmlns:a="http://schemas.openxmlformats.org/drawingml/2006/main">
             <a:r>
-              <a:t>The default reward is forward velocity minus zero point one times squared control effort. The numerical example is illustrative: at five meters per second, six action components of zero point five produce a cost of zero point fifteen, so the reward is four point eight five. This encourages efficient forward motion. The agent should learn a gait that maintains speed throughout the episode. A fall does not terminate HalfCheetah. The time limit is one thousand steps, about fifty simulated seconds. A failed policy can remain on the ground until that limit. Time-limit truncation still preserves next-state value bootstrapping in our learning targets.</a:t>
+              <a:t>Reward is forward velocity minus 0.1 times squared action effort. In this example, speed contributes 5 and control costs 0.15, giving 4.85 reward. The goal is efficient, sustained forward motion. A fall does not end HalfCheetah: the episode lasts 1,000 steps, about 50 simulated seconds. Time-limit truncation preserves next-state value bootstrapping. We inspect complete episodes to detect falls and stalls.</a:t>
             </a:r>
           </a:p>
           <a:p xmlns:a="http://schemas.openxmlformats.org/drawingml/2006/main">
@@ -914,27 +829,7 @@
           </a:p>
           <a:p xmlns:a="http://schemas.openxmlformats.org/drawingml/2006/main">
             <a:r>
-              <a:t>Show: Follow the numerical reward example from speed through effort cost to net reward. Trace the 0-to-50-second episode line. Emphasize that a fall does not end the episode.</a:t>
-            </a:r>
-          </a:p>
-          <a:p xmlns:a="http://schemas.openxmlformats.org/drawingml/2006/main">
-            <a:r>
-              <a:t/>
-            </a:r>
-          </a:p>
-          <a:p xmlns:a="http://schemas.openxmlformats.org/drawingml/2006/main">
-            <a:r>
-              <a:t>Sources:</a:t>
-            </a:r>
-          </a:p>
-          <a:p xmlns:a="http://schemas.openxmlformats.org/drawingml/2006/main">
-            <a:r>
-              <a:t>https://gymnasium.farama.org/environments/mujoco/half_cheetah/</a:t>
-            </a:r>
-          </a:p>
-          <a:p xmlns:a="http://schemas.openxmlformats.org/drawingml/2006/main">
-            <a:r>
-              <a:t>https://github.com/MedvAx-AI/iql-halfcheetah/blob/c372ec0423b81839956ec00dd7338700db8d3737/src/iql_project/iql.py</a:t>
+              <a:t>Sources: [2], [3]. Full references: SLIDE_SOURCES.md.</a:t>
             </a:r>
           </a:p>
         </p:txBody>
@@ -1004,7 +899,7 @@
           <a:lstStyle xmlns:a="http://schemas.openxmlformats.org/drawingml/2006/main"/>
           <a:p xmlns:a="http://schemas.openxmlformats.org/drawingml/2006/main">
             <a:r>
-              <a:t>40 seconds. Suggested speaker: Ruslan Nasibullin.</a:t>
+              <a:t>3:30-3:50</a:t>
             </a:r>
           </a:p>
           <a:p xmlns:a="http://schemas.openxmlformats.org/drawingml/2006/main">
@@ -1014,7 +909,7 @@
           </a:p>
           <a:p xmlns:a="http://schemas.openxmlformats.org/drawingml/2006/main">
             <a:r>
-              <a:t>We use Minari's HalfCheetah medium dataset: one million transitions from one thousand episodes. Our protocol trains three seeds for five hundred thousand offline updates each, with batches of two hundred fifty-six. We evaluate checkpoints over ten episodes, compare raw return with a random baseline, then test the selected checkpoint on separate final episode seeds. We retain full videos and separate episode variation from training-seed variation. MuJoCo three point two point three matches the recorded dataset runtime.</a:t>
+              <a:t>We use one million Minari transitions. Three training seeds receive 500k updates each. Checkpoints use ten evaluation episodes and a random baseline. The selected policy then uses separate final-test seeds. We retain full videos and pin MuJoCo 3.2.3 for reproducibility.</a:t>
             </a:r>
           </a:p>
           <a:p xmlns:a="http://schemas.openxmlformats.org/drawingml/2006/main">
@@ -1024,27 +919,7 @@
           </a:p>
           <a:p xmlns:a="http://schemas.openxmlformats.org/drawingml/2006/main">
             <a:r>
-              <a:t>Show: Point to the large dataset and budget numbers, then follow the training-to-selection-to-final-test timeline. Distinguish training seeds from evaluation episode seeds.</a:t>
-            </a:r>
-          </a:p>
-          <a:p xmlns:a="http://schemas.openxmlformats.org/drawingml/2006/main">
-            <a:r>
-              <a:t/>
-            </a:r>
-          </a:p>
-          <a:p xmlns:a="http://schemas.openxmlformats.org/drawingml/2006/main">
-            <a:r>
-              <a:t>Sources:</a:t>
-            </a:r>
-          </a:p>
-          <a:p xmlns:a="http://schemas.openxmlformats.org/drawingml/2006/main">
-            <a:r>
-              <a:t>https://minari.farama.org/datasets/mujoco/halfcheetah/medium-v0/</a:t>
-            </a:r>
-          </a:p>
-          <a:p xmlns:a="http://schemas.openxmlformats.org/drawingml/2006/main">
-            <a:r>
-              <a:t>https://github.com/MedvAx-AI/iql-halfcheetah/blob/c372ec0423b81839956ec00dd7338700db8d3737/docs/POLICY_CONTINUATION.md</a:t>
+              <a:t>Sources: [3], [5]. Full references: SLIDE_SOURCES.md.</a:t>
             </a:r>
           </a:p>
         </p:txBody>
@@ -1114,7 +989,7 @@
           <a:lstStyle xmlns:a="http://schemas.openxmlformats.org/drawingml/2006/main"/>
           <a:p xmlns:a="http://schemas.openxmlformats.org/drawingml/2006/main">
             <a:r>
-              <a:t>60 seconds. Suggested speaker: Telman Nuruzov.</a:t>
+              <a:t>3:50-4:30</a:t>
             </a:r>
           </a:p>
           <a:p xmlns:a="http://schemas.openxmlformats.org/drawingml/2006/main">
@@ -1124,7 +999,7 @@
           </a:p>
           <a:p xmlns:a="http://schemas.openxmlformats.org/drawingml/2006/main">
             <a:r>
-              <a:t>The match has three practical reasons. Continuous joint torques fit a continuous actor directly. Available offline locomotion data makes training feasible without a new data-collection stage. Finally, numerical returns and visible movement make evaluation understandable. IQL's advantage weighting can favor better recorded actions, but improvement is something to test, not assume. The main challenges are limited coverage, policy variation and simulator differences. We address them with multiple training seeds, pinned dependencies and full-episode evaluation. Aleksandr owns integration, Nikita the environment and data, Leo IQL, Ruslan evaluation, and Telman the notebook and presentation. Our shared outputs are a reproducible Colab, checkpoints, plots and complete rollouts.</a:t>
+              <a:t>HalfCheetah fits IQL because it has continuous controls, available offline data, and measurable locomotion. Advantage weighting can favor better actions, but improvement must be tested. Main challenges are data coverage, seed failures and physics differences. We address them with multiple seeds, pinned dependencies and full-episode evaluation. Team responsibilities and deliverables appear here.</a:t>
             </a:r>
           </a:p>
           <a:p xmlns:a="http://schemas.openxmlformats.org/drawingml/2006/main">
@@ -1134,32 +1009,7 @@
           </a:p>
           <a:p xmlns:a="http://schemas.openxmlformats.org/drawingml/2006/main">
             <a:r>
-              <a:t>Show: Follow the three algorithm-to-task matches. Explain the challenges along the bottom. Point to the team ownership line and name each personâ€™s contribution without reading all slide labels aloud.</a:t>
-            </a:r>
-          </a:p>
-          <a:p xmlns:a="http://schemas.openxmlformats.org/drawingml/2006/main">
-            <a:r>
-              <a:t/>
-            </a:r>
-          </a:p>
-          <a:p xmlns:a="http://schemas.openxmlformats.org/drawingml/2006/main">
-            <a:r>
-              <a:t>Sources:</a:t>
-            </a:r>
-          </a:p>
-          <a:p xmlns:a="http://schemas.openxmlformats.org/drawingml/2006/main">
-            <a:r>
-              <a:t>https://arxiv.org/abs/2110.06169</a:t>
-            </a:r>
-          </a:p>
-          <a:p xmlns:a="http://schemas.openxmlformats.org/drawingml/2006/main">
-            <a:r>
-              <a:t>https://minari.farama.org/datasets/mujoco/halfcheetah/medium-v0/</a:t>
-            </a:r>
-          </a:p>
-          <a:p xmlns:a="http://schemas.openxmlformats.org/drawingml/2006/main">
-            <a:r>
-              <a:t>https://gymnasium.farama.org/environments/mujoco/half_cheetah/</a:t>
+              <a:t>Sources: [1], [2], [3]. Full references: SLIDE_SOURCES.md.</a:t>
             </a:r>
           </a:p>
         </p:txBody>
@@ -1229,7 +1079,7 @@
           <a:lstStyle xmlns:a="http://schemas.openxmlformats.org/drawingml/2006/main"/>
           <a:p xmlns:a="http://schemas.openxmlformats.org/drawingml/2006/main">
             <a:r>
-              <a:t>50 seconds. Suggested speaker: Aleksandr Medvedev.</a:t>
+              <a:t>4:30-5:00</a:t>
             </a:r>
           </a:p>
           <a:p xmlns:a="http://schemas.openxmlformats.org/drawingml/2006/main">
@@ -1239,7 +1089,7 @@
           </a:p>
           <a:p xmlns:a="http://schemas.openxmlformats.org/drawingml/2006/main">
             <a:r>
-              <a:t>This chart shows recorded Colab validation means for all three training seeds at five measured checkpoints. Each point averages ten episodes. Performance varies across seeds, and the lines do not claim values between measurements. The selected seed-one policy reached a raw return of about fifteen thousand two hundred sixty on ten separate final-test episodes, compared with about two thousand twenty-six at one hundred thousand updates. Long stationary tails decreased from ten out of ten episodes to zero out of ten. Those tails mean at least five seconds of very slow movement at the end. Other training seeds still fail, and these samples do not guarantee success everywhere. The evidence supports feasibility while preserving the limits. Thank you.</a:t>
+              <a:t>The curves show measured means for all three training seeds, with ten episodes per point. On ten separate final-test episodes, selected seed 1 achieved about 15,260 return versus 2,026 at 100k. Long stationary tails decreased from ten episodes to zero. Other training seeds still fail, so these results demonstrate feasibility rather than guaranteed success. Thank you.</a:t>
             </a:r>
           </a:p>
           <a:p xmlns:a="http://schemas.openxmlformats.org/drawingml/2006/main">
@@ -1249,42 +1099,7 @@
           </a:p>
           <a:p xmlns:a="http://schemas.openxmlformats.org/drawingml/2006/main">
             <a:r>
-              <a:t>Show: Trace all three measured curves. Point to the separate final-test return and stationary-tail counts. Say the other-seed limitation clearly, then pause on the closing slide.</a:t>
-            </a:r>
-          </a:p>
-          <a:p xmlns:a="http://schemas.openxmlformats.org/drawingml/2006/main">
-            <a:r>
-              <a:t/>
-            </a:r>
-          </a:p>
-          <a:p xmlns:a="http://schemas.openxmlformats.org/drawingml/2006/main">
-            <a:r>
-              <a:t>Sources:</a:t>
-            </a:r>
-          </a:p>
-          <a:p xmlns:a="http://schemas.openxmlformats.org/drawingml/2006/main">
-            <a:r>
-              <a:t>https://github.com/MedvAx-AI/iql-halfcheetah</a:t>
-            </a:r>
-          </a:p>
-          <a:p xmlns:a="http://schemas.openxmlformats.org/drawingml/2006/main">
-            <a:r>
-              <a:t>https://github.com/MedvAx-AI/iql-halfcheetah/blob/c372ec0423b81839956ec00dd7338700db8d3737/docs/POLICY_CONTINUATION.md</a:t>
-            </a:r>
-          </a:p>
-          <a:p xmlns:a="http://schemas.openxmlformats.org/drawingml/2006/main">
-            <a:r>
-              <a:t>https://github.com/MedvAx-AI/iql-halfcheetah/blob/aa9ad5baec910730502e1f24459325b5f273b952/docs/evidence/continuation/validation/summary.json</a:t>
-            </a:r>
-          </a:p>
-          <a:p xmlns:a="http://schemas.openxmlformats.org/drawingml/2006/main">
-            <a:r>
-              <a:t>https://github.com/MedvAx-AI/iql-halfcheetah/blob/aa9ad5baec910730502e1f24459325b5f273b952/docs/evidence/continuation/independent-final-test.json</a:t>
-            </a:r>
-          </a:p>
-          <a:p xmlns:a="http://schemas.openxmlformats.org/drawingml/2006/main">
-            <a:r>
-              <a:t>Long stationary tail: at least 5 seconds at the end with absolute forward velocity &lt;= 0.1 m/s. Descriptive diagnostic, not a standard benchmark success score.</a:t>
+              <a:t>Sources: [6]. Full references: SLIDE_SOURCES.md.</a:t>
             </a:r>
           </a:p>
         </p:txBody>

</xml_diff>

<commit_message>
Add Colab and repository hyperlinks to proposal cover
</commit_message>
<xml_diff>
--- a/docs/presentation/IQL_RL_Proposal.pptx
+++ b/docs/presentation/IQL_RL_Proposal.pptx
@@ -3943,11 +3943,11 @@
 </file>
 
 <file path=ppt/slides/slide1.xml><?xml version="1.0" encoding="utf-8"?>
-<p:sld xmlns:p="http://schemas.openxmlformats.org/presentationml/2006/main">
+<p:sld xmlns:a="http://schemas.openxmlformats.org/drawingml/2006/main" xmlns:ns2="http://schemas.microsoft.com/office/drawing/2014/main" xmlns:ns4="http://schemas.microsoft.com/office/powerpoint/2010/main" xmlns:p="http://schemas.openxmlformats.org/presentationml/2006/main" xmlns:r="http://schemas.openxmlformats.org/officeDocument/2006/relationships">
   <p:cSld>
     <p:bg>
       <p:bgPr>
-        <a:solidFill xmlns:a="http://schemas.openxmlformats.org/drawingml/2006/main">
+        <a:solidFill>
           <a:srgbClr val="112D3D"/>
         </a:solidFill>
       </p:bgPr>
@@ -3959,38 +3959,38 @@
         <p:nvPr/>
       </p:nvGrpSpPr>
       <p:grpSpPr>
-        <a:xfrm xmlns:a="http://schemas.openxmlformats.org/drawingml/2006/main"/>
+        <a:xfrm/>
       </p:grpSpPr>
       <p:sp>
         <p:nvSpPr>
           <p:cNvPr id="6" name="">
-            <a:extLst xmlns:a="http://schemas.openxmlformats.org/drawingml/2006/main">
-              <a:ext uri="{FF2B5EF4-FFF2-40B4-BE49-F238E27FC236}">
-                <a16:creationId xmlns:a16="http://schemas.microsoft.com/office/drawing/2014/main" id="{13523960-0F0D-4DF4-ADA8-B88590B09DEA}"/>
-              </a:ext>
-            </a:extLst>
-          </p:cNvPr>
-          <p:cNvSpPr>
-            <a:spLocks xmlns:a="http://schemas.openxmlformats.org/drawingml/2006/main" noGrp="1"/>
+            <a:extLst>
+              <a:ext uri="{FF2B5EF4-FFF2-40B4-BE49-F238E27FC236}">
+                <ns2:creationId id="{13523960-0F0D-4DF4-ADA8-B88590B09DEA}"/>
+              </a:ext>
+            </a:extLst>
+          </p:cNvPr>
+          <p:cNvSpPr>
+            <a:spLocks noGrp="1"/>
           </p:cNvSpPr>
           <p:nvPr/>
         </p:nvSpPr>
         <p:spPr>
-          <a:xfrm xmlns:a="http://schemas.openxmlformats.org/drawingml/2006/main">
+          <a:xfrm>
             <a:off x="609600" y="1104900"/>
             <a:ext cx="5619750" cy="2019300"/>
           </a:xfrm>
-          <a:prstGeom xmlns:a="http://schemas.openxmlformats.org/drawingml/2006/main" prst="rect">
-            <a:avLst/>
-          </a:prstGeom>
-          <a:noFill xmlns:a="http://schemas.openxmlformats.org/drawingml/2006/main"/>
-          <a:ln xmlns:a="http://schemas.openxmlformats.org/drawingml/2006/main" w="0">
-            <a:noFill/>
-          </a:ln>
-        </p:spPr>
-        <p:txBody>
-          <a:bodyPr xmlns:a="http://schemas.openxmlformats.org/drawingml/2006/main" lIns="0" tIns="0" rIns="0" bIns="0"/>
-          <a:lstStyle xmlns:a="http://schemas.openxmlformats.org/drawingml/2006/main">
+          <a:prstGeom prst="rect">
+            <a:avLst/>
+          </a:prstGeom>
+          <a:noFill/>
+          <a:ln w="0">
+            <a:noFill/>
+          </a:ln>
+        </p:spPr>
+        <p:txBody>
+          <a:bodyPr lIns="0" tIns="0" rIns="0" bIns="0"/>
+          <a:lstStyle>
             <a:defPPr algn="l">
               <a:defRPr sz="6300" b="1">
                 <a:solidFill>
@@ -4002,7 +4002,7 @@
               </a:defRPr>
             </a:defPPr>
           </a:lstStyle>
-          <a:p xmlns:a="http://schemas.openxmlformats.org/drawingml/2006/main">
+          <a:p>
             <a:pPr algn="l">
               <a:defRPr sz="6300" b="1">
                 <a:solidFill>
@@ -4025,7 +4025,7 @@
               <a:t>Implicit</a:t>
             </a:r>
           </a:p>
-          <a:p xmlns:a="http://schemas.openxmlformats.org/drawingml/2006/main">
+          <a:p>
             <a:pPr algn="l">
               <a:defRPr sz="6300" b="1">
                 <a:solidFill>
@@ -4053,33 +4053,33 @@
       <p:sp>
         <p:nvSpPr>
           <p:cNvPr id="2" name="">
-            <a:extLst xmlns:a="http://schemas.openxmlformats.org/drawingml/2006/main">
-              <a:ext uri="{FF2B5EF4-FFF2-40B4-BE49-F238E27FC236}">
-                <a16:creationId xmlns:a16="http://schemas.microsoft.com/office/drawing/2014/main" id="{6295A5AF-486C-4922-934D-D4F10E58CBF5}"/>
-              </a:ext>
-            </a:extLst>
-          </p:cNvPr>
-          <p:cNvSpPr>
-            <a:spLocks xmlns:a="http://schemas.openxmlformats.org/drawingml/2006/main" noGrp="1"/>
+            <a:extLst>
+              <a:ext uri="{FF2B5EF4-FFF2-40B4-BE49-F238E27FC236}">
+                <ns2:creationId id="{6295A5AF-486C-4922-934D-D4F10E58CBF5}"/>
+              </a:ext>
+            </a:extLst>
+          </p:cNvPr>
+          <p:cNvSpPr>
+            <a:spLocks noGrp="1"/>
           </p:cNvSpPr>
           <p:nvPr/>
         </p:nvSpPr>
         <p:spPr>
-          <a:xfrm xmlns:a="http://schemas.openxmlformats.org/drawingml/2006/main">
+          <a:xfrm>
             <a:off x="609600" y="3476625"/>
             <a:ext cx="5715000" cy="685800"/>
           </a:xfrm>
-          <a:prstGeom xmlns:a="http://schemas.openxmlformats.org/drawingml/2006/main" prst="rect">
-            <a:avLst/>
-          </a:prstGeom>
-          <a:noFill xmlns:a="http://schemas.openxmlformats.org/drawingml/2006/main"/>
-          <a:ln xmlns:a="http://schemas.openxmlformats.org/drawingml/2006/main" w="0">
-            <a:noFill/>
-          </a:ln>
-        </p:spPr>
-        <p:txBody>
-          <a:bodyPr xmlns:a="http://schemas.openxmlformats.org/drawingml/2006/main" lIns="0" tIns="0" rIns="0" bIns="0"/>
-          <a:lstStyle xmlns:a="http://schemas.openxmlformats.org/drawingml/2006/main">
+          <a:prstGeom prst="rect">
+            <a:avLst/>
+          </a:prstGeom>
+          <a:noFill/>
+          <a:ln w="0">
+            <a:noFill/>
+          </a:ln>
+        </p:spPr>
+        <p:txBody>
+          <a:bodyPr lIns="0" tIns="0" rIns="0" bIns="0"/>
+          <a:lstStyle>
             <a:defPPr algn="l">
               <a:defRPr sz="3750" b="1">
                 <a:solidFill>
@@ -4091,7 +4091,7 @@
               </a:defRPr>
             </a:defPPr>
           </a:lstStyle>
-          <a:p xmlns:a="http://schemas.openxmlformats.org/drawingml/2006/main">
+          <a:p>
             <a:pPr algn="l">
               <a:defRPr sz="3750" b="1">
                 <a:solidFill>
@@ -4119,33 +4119,33 @@
       <p:sp>
         <p:nvSpPr>
           <p:cNvPr id="3" name="">
-            <a:extLst xmlns:a="http://schemas.openxmlformats.org/drawingml/2006/main">
-              <a:ext uri="{FF2B5EF4-FFF2-40B4-BE49-F238E27FC236}">
-                <a16:creationId xmlns:a16="http://schemas.microsoft.com/office/drawing/2014/main" id="{C060235E-A541-47ED-81C4-DFCFFF0967BF}"/>
-              </a:ext>
-            </a:extLst>
-          </p:cNvPr>
-          <p:cNvSpPr>
-            <a:spLocks xmlns:a="http://schemas.openxmlformats.org/drawingml/2006/main" noGrp="1"/>
+            <a:extLst>
+              <a:ext uri="{FF2B5EF4-FFF2-40B4-BE49-F238E27FC236}">
+                <ns2:creationId id="{C060235E-A541-47ED-81C4-DFCFFF0967BF}"/>
+              </a:ext>
+            </a:extLst>
+          </p:cNvPr>
+          <p:cNvSpPr>
+            <a:spLocks noGrp="1"/>
           </p:cNvSpPr>
           <p:nvPr/>
         </p:nvSpPr>
         <p:spPr>
-          <a:xfrm xmlns:a="http://schemas.openxmlformats.org/drawingml/2006/main">
+          <a:xfrm>
             <a:off x="609600" y="4295775"/>
             <a:ext cx="6191250" cy="495300"/>
           </a:xfrm>
-          <a:prstGeom xmlns:a="http://schemas.openxmlformats.org/drawingml/2006/main" prst="rect">
-            <a:avLst/>
-          </a:prstGeom>
-          <a:noFill xmlns:a="http://schemas.openxmlformats.org/drawingml/2006/main"/>
-          <a:ln xmlns:a="http://schemas.openxmlformats.org/drawingml/2006/main" w="0">
-            <a:noFill/>
-          </a:ln>
-        </p:spPr>
-        <p:txBody>
-          <a:bodyPr xmlns:a="http://schemas.openxmlformats.org/drawingml/2006/main" lIns="0" tIns="0" rIns="0" bIns="0"/>
-          <a:lstStyle xmlns:a="http://schemas.openxmlformats.org/drawingml/2006/main">
+          <a:prstGeom prst="rect">
+            <a:avLst/>
+          </a:prstGeom>
+          <a:noFill/>
+          <a:ln w="0">
+            <a:noFill/>
+          </a:ln>
+        </p:spPr>
+        <p:txBody>
+          <a:bodyPr lIns="0" tIns="0" rIns="0" bIns="0"/>
+          <a:lstStyle>
             <a:defPPr algn="l">
               <a:defRPr sz="2400" b="0">
                 <a:solidFill>
@@ -4157,7 +4157,7 @@
               </a:defRPr>
             </a:defPPr>
           </a:lstStyle>
-          <a:p xmlns:a="http://schemas.openxmlformats.org/drawingml/2006/main">
+          <a:p>
             <a:pPr algn="l">
               <a:defRPr sz="2400" b="0">
                 <a:solidFill>
@@ -4185,27 +4185,27 @@
       <p:pic>
         <p:nvPicPr>
           <p:cNvPr id="4" name="">
-            <a:extLst xmlns:a="http://schemas.openxmlformats.org/drawingml/2006/main">
-              <a:ext uri="{FF2B5EF4-FFF2-40B4-BE49-F238E27FC236}">
-                <a16:creationId xmlns:a16="http://schemas.microsoft.com/office/drawing/2014/main" id="{B33F9EC7-77F2-4E67-91B5-843441801DDE}"/>
+            <a:extLst>
+              <a:ext uri="{FF2B5EF4-FFF2-40B4-BE49-F238E27FC236}">
+                <ns2:creationId id="{B33F9EC7-77F2-4E67-91B5-843441801DDE}"/>
               </a:ext>
             </a:extLst>
           </p:cNvPr>
           <p:cNvPicPr>
-            <a:picLocks xmlns:a="http://schemas.openxmlformats.org/drawingml/2006/main" noChangeAspect="1"/>
+            <a:picLocks noChangeAspect="1"/>
           </p:cNvPicPr>
           <p:nvPr/>
         </p:nvPicPr>
         <p:blipFill>
-          <a:blip xmlns:r="http://schemas.openxmlformats.org/officeDocument/2006/relationships" xmlns:a="http://schemas.openxmlformats.org/drawingml/2006/main" r:embed="Rd12b72b076d44a07"/>
-          <a:stretch xmlns:a="http://schemas.openxmlformats.org/drawingml/2006/main"/>
+          <a:blip r:embed="Rd12b72b076d44a07"/>
+          <a:stretch/>
         </p:blipFill>
         <p:spPr>
-          <a:xfrm xmlns:a="http://schemas.openxmlformats.org/drawingml/2006/main">
+          <a:xfrm>
             <a:off x="6638925" y="1600498"/>
             <a:ext cx="4943475" cy="2780705"/>
           </a:xfrm>
-          <a:prstGeom xmlns:a="http://schemas.openxmlformats.org/drawingml/2006/main" prst="rect">
+          <a:prstGeom prst="rect">
             <a:avLst/>
           </a:prstGeom>
         </p:spPr>
@@ -4213,33 +4213,33 @@
       <p:sp>
         <p:nvSpPr>
           <p:cNvPr id="5" name="">
-            <a:extLst xmlns:a="http://schemas.openxmlformats.org/drawingml/2006/main">
-              <a:ext uri="{FF2B5EF4-FFF2-40B4-BE49-F238E27FC236}">
-                <a16:creationId xmlns:a16="http://schemas.microsoft.com/office/drawing/2014/main" id="{2E4EBB61-2487-45B9-A529-5A18364DEDCB}"/>
-              </a:ext>
-            </a:extLst>
-          </p:cNvPr>
-          <p:cNvSpPr>
-            <a:spLocks xmlns:a="http://schemas.openxmlformats.org/drawingml/2006/main" noGrp="1"/>
+            <a:extLst>
+              <a:ext uri="{FF2B5EF4-FFF2-40B4-BE49-F238E27FC236}">
+                <ns2:creationId id="{2E4EBB61-2487-45B9-A529-5A18364DEDCB}"/>
+              </a:ext>
+            </a:extLst>
+          </p:cNvPr>
+          <p:cNvSpPr>
+            <a:spLocks noGrp="1"/>
           </p:cNvSpPr>
           <p:nvPr/>
         </p:nvSpPr>
         <p:spPr>
-          <a:xfrm xmlns:a="http://schemas.openxmlformats.org/drawingml/2006/main">
+          <a:xfrm>
             <a:off x="609600" y="5514975"/>
             <a:ext cx="10763250" cy="838200"/>
           </a:xfrm>
-          <a:prstGeom xmlns:a="http://schemas.openxmlformats.org/drawingml/2006/main" prst="rect">
-            <a:avLst/>
-          </a:prstGeom>
-          <a:noFill xmlns:a="http://schemas.openxmlformats.org/drawingml/2006/main"/>
-          <a:ln xmlns:a="http://schemas.openxmlformats.org/drawingml/2006/main" w="0">
-            <a:noFill/>
-          </a:ln>
-        </p:spPr>
-        <p:txBody>
-          <a:bodyPr xmlns:a="http://schemas.openxmlformats.org/drawingml/2006/main" lIns="0" tIns="0" rIns="0" bIns="0"/>
-          <a:lstStyle xmlns:a="http://schemas.openxmlformats.org/drawingml/2006/main">
+          <a:prstGeom prst="rect">
+            <a:avLst/>
+          </a:prstGeom>
+          <a:noFill/>
+          <a:ln w="0">
+            <a:noFill/>
+          </a:ln>
+        </p:spPr>
+        <p:txBody>
+          <a:bodyPr lIns="0" tIns="0" rIns="0" bIns="0"/>
+          <a:lstStyle>
             <a:defPPr algn="l">
               <a:defRPr sz="2175" b="0">
                 <a:solidFill>
@@ -4251,7 +4251,7 @@
               </a:defRPr>
             </a:defPPr>
           </a:lstStyle>
-          <a:p xmlns:a="http://schemas.openxmlformats.org/drawingml/2006/main">
+          <a:p>
             <a:pPr algn="l">
               <a:defRPr sz="2175" b="0">
                 <a:solidFill>
@@ -4274,7 +4274,7 @@
               <a:t>Aleksandr Medvedev   Nikita Shankin   Leo Vesin</a:t>
             </a:r>
           </a:p>
-          <a:p xmlns:a="http://schemas.openxmlformats.org/drawingml/2006/main">
+          <a:p>
             <a:pPr algn="l">
               <a:defRPr sz="2175" b="0">
                 <a:solidFill>
@@ -4295,6 +4295,140 @@
                 <a:cs typeface="Arial"/>
               </a:rPr>
               <a:t>Ruslan Nasibullin   Telman Nuruzov</a:t>
+            </a:r>
+          </a:p>
+        </p:txBody>
+      </p:sp>
+      <p:sp>
+        <p:nvSpPr>
+          <p:cNvPr id="7" name="colab-link">
+            <a:extLst>
+              <a:ext uri="{FF2B5EF4-FFF2-40B4-BE49-F238E27FC236}">
+                <ns2:creationId id="{88DDBF00-78C6-4C72-80F8-E84C291B9440}"/>
+              </a:ext>
+            </a:extLst>
+          </p:cNvPr>
+          <p:cNvSpPr>
+            <a:spLocks noGrp="1"/>
+          </p:cNvSpPr>
+          <p:nvPr/>
+        </p:nvSpPr>
+        <p:spPr>
+          <a:xfrm>
+            <a:off x="7010400" y="4619625"/>
+            <a:ext cx="4572000" cy="400050"/>
+          </a:xfrm>
+          <a:prstGeom prst="rect">
+            <a:avLst/>
+          </a:prstGeom>
+          <a:noFill/>
+          <a:ln w="0">
+            <a:noFill/>
+          </a:ln>
+        </p:spPr>
+        <p:txBody>
+          <a:bodyPr lIns="0" tIns="0" rIns="0" bIns="0"/>
+          <a:lstStyle>
+            <a:defPPr>
+              <a:defRPr sz="2100">
+                <a:solidFill>
+                  <a:srgbClr val="70D9CA"/>
+                </a:solidFill>
+                <a:latin typeface="Arial"/>
+                <a:ea typeface="Arial"/>
+                <a:cs typeface="Arial"/>
+              </a:defRPr>
+            </a:defPPr>
+          </a:lstStyle>
+          <a:p>
+            <a:pPr>
+              <a:defRPr sz="2100">
+                <a:solidFill>
+                  <a:srgbClr val="70D9CA"/>
+                </a:solidFill>
+                <a:latin typeface="Arial"/>
+                <a:ea typeface="Arial"/>
+                <a:cs typeface="Arial"/>
+              </a:defRPr>
+            </a:pPr>
+            <a:r>
+              <a:rPr sz="2100" u="sng">
+                <a:solidFill>
+                  <a:srgbClr val="70D9CA"/>
+                </a:solidFill>
+                <a:latin typeface="Arial"/>
+                <a:ea typeface="Arial"/>
+                <a:cs typeface="Arial"/>
+                <a:hlinkClick r:id="rId1"/>
+              </a:rPr>
+              <a:t>Open notebook in Colab</a:t>
+            </a:r>
+          </a:p>
+        </p:txBody>
+      </p:sp>
+      <p:sp>
+        <p:nvSpPr>
+          <p:cNvPr id="8" name="github-link">
+            <a:extLst>
+              <a:ext uri="{FF2B5EF4-FFF2-40B4-BE49-F238E27FC236}">
+                <ns2:creationId id="{4972675B-6F4E-4218-895B-B818B3E98B97}"/>
+              </a:ext>
+            </a:extLst>
+          </p:cNvPr>
+          <p:cNvSpPr>
+            <a:spLocks noGrp="1"/>
+          </p:cNvSpPr>
+          <p:nvPr/>
+        </p:nvSpPr>
+        <p:spPr>
+          <a:xfrm>
+            <a:off x="7010400" y="5048250"/>
+            <a:ext cx="4572000" cy="400050"/>
+          </a:xfrm>
+          <a:prstGeom prst="rect">
+            <a:avLst/>
+          </a:prstGeom>
+          <a:noFill/>
+          <a:ln w="0">
+            <a:noFill/>
+          </a:ln>
+        </p:spPr>
+        <p:txBody>
+          <a:bodyPr lIns="0" tIns="0" rIns="0" bIns="0"/>
+          <a:lstStyle>
+            <a:defPPr>
+              <a:defRPr sz="2100">
+                <a:solidFill>
+                  <a:srgbClr val="70D9CA"/>
+                </a:solidFill>
+                <a:latin typeface="Arial"/>
+                <a:ea typeface="Arial"/>
+                <a:cs typeface="Arial"/>
+              </a:defRPr>
+            </a:defPPr>
+          </a:lstStyle>
+          <a:p>
+            <a:pPr>
+              <a:defRPr sz="2100">
+                <a:solidFill>
+                  <a:srgbClr val="70D9CA"/>
+                </a:solidFill>
+                <a:latin typeface="Arial"/>
+                <a:ea typeface="Arial"/>
+                <a:cs typeface="Arial"/>
+              </a:defRPr>
+            </a:pPr>
+            <a:r>
+              <a:rPr sz="2100" u="sng">
+                <a:solidFill>
+                  <a:srgbClr val="70D9CA"/>
+                </a:solidFill>
+                <a:latin typeface="Arial"/>
+                <a:ea typeface="Arial"/>
+                <a:cs typeface="Arial"/>
+                <a:hlinkClick r:id="rId2"/>
+              </a:rPr>
+              <a:t>GitHub repository</a:t>
             </a:r>
           </a:p>
         </p:txBody>
@@ -4302,7 +4436,7 @@
     </p:spTree>
     <p:extLst>
       <p:ext uri="{BB962C8B-B14F-4D97-AF65-F5344CB8AC3E}">
-        <p14:creationId xmlns:p14="http://schemas.microsoft.com/office/powerpoint/2010/main" val="1222042575"/>
+        <ns4:creationId val="1222042575"/>
       </p:ext>
     </p:extLst>
   </p:cSld>

</xml_diff>